<commit_message>
chore: v0.2.5 移除 zhifang-atelier 演示报告(防泄露)
删除 metric-brand-auditor/reports/zhifang-atelier/ 下全部 17 个文件
(report.md/html · 7 个 _raw/dimension · synthesis · wuying_browse ·
 v1 versions · 5 评委 reviews)。

更新 8 处外部引用:
- README.md:目录树 / 文件路标 / 边界声明
- docs/01-prd.md:成功指标里的品牌列表
- docs/03-architecture.md:slug 例子 + 数据格式约定
- docs/05-usage.md:示例 brand 名 + list 输出
- docs/06-installation.md:校验步骤改为"reports 为空"
- scripts/build_hackathon_deck.py:slide 8 完成清单 + slide 11 链接

新增 reports/ 隐私警告:跑完审计的报告默认会进 git status,
建议自行 gitignore。

仓库现在不附任何品牌的样板报告 —— 报告归用户所有。

Co-Authored-By: Claude Opus 4.7 <noreply@anthropic.com>
</commit_message>
<xml_diff>
--- a/docs/hackathon/mba-hackathon-deck.pptx
+++ b/docs/hackathon/mba-hackathon-deck.pptx
@@ -5312,7 +5312,7 @@
                 </a:solidFill>
                 <a:latin typeface="PingFang SC"/>
               </a:rPr>
-              <a:t>🦞  Demo 报告</a:t>
+              <a:t>⚡  现场跑一次</a:t>
             </a:r>
           </a:p>
         </p:txBody>
@@ -5347,7 +5347,7 @@
                 </a:solidFill>
                 <a:latin typeface="Menlo"/>
               </a:rPr>
-              <a:t>/metric-brand-auditor/reports/zhifang-atelier/report.html</a:t>
+              <a:t>/mba YourBrand  →  ~25 min 出报告</a:t>
             </a:r>
           </a:p>
         </p:txBody>
@@ -5382,7 +5382,7 @@
                 </a:solidFill>
                 <a:latin typeface="PingFang SC"/>
               </a:rPr>
-              <a:t>现场演示请到 reports/zhifang-atelier/report.html</a:t>
+              <a:t>现场演示:/mba &lt;一个评委你想看的品牌&gt;</a:t>
             </a:r>
           </a:p>
         </p:txBody>
@@ -16623,7 +16623,7 @@
                 </a:solidFill>
                 <a:latin typeface="PingFang SC"/>
               </a:rPr>
-              <a:t>演示报告:zhifang-atelier v1</a:t>
+              <a:t>自包含 HTML 报告(Chart.js + Mermaid · 9 块)</a:t>
             </a:r>
           </a:p>
           <a:p>
@@ -16639,7 +16639,7 @@
                 </a:solidFill>
                 <a:latin typeface="PingFang SC"/>
               </a:rPr>
-              <a:t>• 完整 _raw / reviews / report.{md,html}</a:t>
+              <a:t>• 雷达图 / 异议热力图 / 影响力流程图 / 定位象限</a:t>
             </a:r>
           </a:p>
           <a:p>

</xml_diff>